<commit_message>
docs: explain early combat and pressure signals
</commit_message>
<xml_diff>
--- a/docs/presentation/LoL_AI_플랫폼_발표_2026-07-21_v5_모델_AI리포트.pptx
+++ b/docs/presentation/LoL_AI_플랫폼_발표_2026-07-21_v5_모델_AI리포트.pptx
@@ -2,24 +2,24 @@
 <file path=ppt/presentation.xml><?xml version="1.0" encoding="utf-8"?>
 <p:presentation xmlns:p="http://schemas.openxmlformats.org/presentationml/2006/main">
   <p:sldMasterIdLst>
-    <p:sldMasterId xmlns:r="http://schemas.openxmlformats.org/officeDocument/2006/relationships" id="2147483648" r:id="Rde36bff56d89464a"/>
+    <p:sldMasterId xmlns:r="http://schemas.openxmlformats.org/officeDocument/2006/relationships" id="2147483648" r:id="R2e62f45ec4df461d"/>
   </p:sldMasterIdLst>
   <p:notesMasterIdLst>
-    <p:notesMasterId xmlns:r="http://schemas.openxmlformats.org/officeDocument/2006/relationships" r:id="R32794a0aa4ab449e"/>
+    <p:notesMasterId xmlns:r="http://schemas.openxmlformats.org/officeDocument/2006/relationships" r:id="Rd3a77dffeb9e435a"/>
   </p:notesMasterIdLst>
   <p:sldIdLst>
-    <p:sldId xmlns:r="http://schemas.openxmlformats.org/officeDocument/2006/relationships" id="256" r:id="Ra3d3ab1cc66f4a6e"/>
-    <p:sldId xmlns:r="http://schemas.openxmlformats.org/officeDocument/2006/relationships" id="257" r:id="R9edfad2d02c24edb"/>
-    <p:sldId xmlns:r="http://schemas.openxmlformats.org/officeDocument/2006/relationships" id="258" r:id="R9651d32e0c18411e"/>
-    <p:sldId xmlns:r="http://schemas.openxmlformats.org/officeDocument/2006/relationships" id="259" r:id="R124cbab3989149fe"/>
-    <p:sldId xmlns:r="http://schemas.openxmlformats.org/officeDocument/2006/relationships" id="260" r:id="R0e21470b6c9e4c39"/>
-    <p:sldId xmlns:r="http://schemas.openxmlformats.org/officeDocument/2006/relationships" id="261" r:id="R6005f4d312e84c15"/>
-    <p:sldId xmlns:r="http://schemas.openxmlformats.org/officeDocument/2006/relationships" id="262" r:id="R35a28c7af9994684"/>
-    <p:sldId xmlns:r="http://schemas.openxmlformats.org/officeDocument/2006/relationships" id="263" r:id="Re7f434d5fb8b4c65"/>
-    <p:sldId xmlns:r="http://schemas.openxmlformats.org/officeDocument/2006/relationships" id="264" r:id="R2f0a78e58b364a4a"/>
-    <p:sldId xmlns:r="http://schemas.openxmlformats.org/officeDocument/2006/relationships" id="265" r:id="Re842ba7a6f604478"/>
-    <p:sldId xmlns:r="http://schemas.openxmlformats.org/officeDocument/2006/relationships" id="266" r:id="R2232d82f114b42d5"/>
-    <p:sldId xmlns:r="http://schemas.openxmlformats.org/officeDocument/2006/relationships" id="267" r:id="R0410f53c04f74f26"/>
+    <p:sldId xmlns:r="http://schemas.openxmlformats.org/officeDocument/2006/relationships" id="256" r:id="Re8098fcef1424134"/>
+    <p:sldId xmlns:r="http://schemas.openxmlformats.org/officeDocument/2006/relationships" id="257" r:id="Rbdb229e3bd234412"/>
+    <p:sldId xmlns:r="http://schemas.openxmlformats.org/officeDocument/2006/relationships" id="258" r:id="R4cf4df20fda8492b"/>
+    <p:sldId xmlns:r="http://schemas.openxmlformats.org/officeDocument/2006/relationships" id="259" r:id="Rc3240d0a66e841a9"/>
+    <p:sldId xmlns:r="http://schemas.openxmlformats.org/officeDocument/2006/relationships" id="260" r:id="R1b4a55b2408f4ed5"/>
+    <p:sldId xmlns:r="http://schemas.openxmlformats.org/officeDocument/2006/relationships" id="261" r:id="Rdb9eca84a8f14420"/>
+    <p:sldId xmlns:r="http://schemas.openxmlformats.org/officeDocument/2006/relationships" id="262" r:id="R96933e2aa2bc42bb"/>
+    <p:sldId xmlns:r="http://schemas.openxmlformats.org/officeDocument/2006/relationships" id="263" r:id="Rd5a1d13edae142fb"/>
+    <p:sldId xmlns:r="http://schemas.openxmlformats.org/officeDocument/2006/relationships" id="264" r:id="R8541684f9d534e20"/>
+    <p:sldId xmlns:r="http://schemas.openxmlformats.org/officeDocument/2006/relationships" id="265" r:id="R37c15ec0992343fc"/>
+    <p:sldId xmlns:r="http://schemas.openxmlformats.org/officeDocument/2006/relationships" id="266" r:id="R8c7a85192eca41aa"/>
+    <p:sldId xmlns:r="http://schemas.openxmlformats.org/officeDocument/2006/relationships" id="267" r:id="R338073d056b740fc"/>
   </p:sldIdLst>
   <p:sldSz cx="12192000" cy="6858000"/>
   <p:notesSz cx="6858000" cy="9144000"/>
@@ -1426,7 +1426,7 @@
   </p:cSld>
   <p:clrMap bg1="lt1" tx1="dk1" bg2="lt2" tx2="dk2" accent1="accent1" accent2="accent2" accent3="accent3" accent4="accent4" accent5="accent5" accent6="accent6" hlink="hlink" folHlink="folHlink"/>
   <p:sldLayoutIdLst>
-    <p:sldLayoutId xmlns:r="http://schemas.openxmlformats.org/officeDocument/2006/relationships" id="2147483649" r:id="R4df7bfed22674018"/>
+    <p:sldLayoutId xmlns:r="http://schemas.openxmlformats.org/officeDocument/2006/relationships" id="2147483649" r:id="R9be435eba1384e3e"/>
   </p:sldLayoutIdLst>
   <p:hf sldNum="0" hdr="0" ftr="0" dt="0"/>
   <p:txStyles>
@@ -3960,7 +3960,7 @@
         </p:xfrm>
         <a:graphic xmlns:a="http://schemas.openxmlformats.org/drawingml/2006/main">
           <a:graphicData uri="http://schemas.openxmlformats.org/drawingml/2006/chart">
-            <c:chart xmlns:r="http://schemas.openxmlformats.org/officeDocument/2006/relationships" xmlns:c="http://schemas.openxmlformats.org/drawingml/2006/chart" r:id="R11907c0f32114ba6"/>
+            <c:chart xmlns:r="http://schemas.openxmlformats.org/officeDocument/2006/relationships" xmlns:c="http://schemas.openxmlformats.org/drawingml/2006/chart" r:id="R6433edea35094931"/>
           </a:graphicData>
         </a:graphic>
       </p:graphicFrame>
@@ -6470,7 +6470,7 @@
                 <a:ea typeface="Noto Sans KR"/>
                 <a:cs typeface="Noto Sans KR"/>
               </a:rPr>
-              <a:t>10종</a:t>
+              <a:t>11종</a:t>
             </a:r>
           </a:p>
         </p:txBody>
@@ -8072,7 +8072,7 @@
                 <a:ea typeface="Noto Sans KR"/>
                 <a:cs typeface="Noto Sans KR"/>
               </a:rPr>
-              <a:t>지표 10종·에피소드</a:t>
+              <a:t>지표 11종·에피소드</a:t>
             </a:r>
           </a:p>
           <a:p xmlns:a="http://schemas.openxmlformats.org/drawingml/2006/main">
@@ -8646,20 +8646,23 @@
                 <a:spcPts val="1000"/>
               </a:spcAft>
               <a:buChar char="•"/>
-              <a:defRPr>
-                <a:latin typeface="Noto Sans KR"/>
-                <a:ea typeface="Noto Sans KR"/>
-                <a:cs typeface="Noto Sans KR"/>
-              </a:defRPr>
-            </a:pPr>
-            <a:r>
-              <a:rPr sz="1400">
-                <a:solidFill>
-                  <a:srgbClr val="1E2A3A"/>
-                </a:solidFill>
-                <a:latin typeface="Malgun Gothic"/>
-                <a:ea typeface="Malgun Gothic"/>
-                <a:cs typeface="Malgun Gothic"/>
+              <a:defRPr sz="1350">
+                <a:solidFill>
+                  <a:srgbClr val="334155"/>
+                </a:solidFill>
+                <a:latin typeface="Noto Sans KR"/>
+                <a:ea typeface="Noto Sans KR"/>
+                <a:cs typeface="Noto Sans KR"/>
+              </a:defRPr>
+            </a:pPr>
+            <a:r>
+              <a:rPr sz="1350">
+                <a:solidFill>
+                  <a:srgbClr val="334155"/>
+                </a:solidFill>
+                <a:latin typeface="Noto Sans KR"/>
+                <a:ea typeface="Noto Sans KR"/>
+                <a:cs typeface="Noto Sans KR"/>
               </a:rPr>
               <a:t>모든 수치·패턴은 규칙 코드가 계산 — LLM은 새 숫자를 만들 수 없음 (환각 통제 + 비용 절감)</a:t>
             </a:r>
@@ -8670,20 +8673,23 @@
                 <a:spcPts val="1000"/>
               </a:spcAft>
               <a:buChar char="•"/>
-              <a:defRPr>
-                <a:latin typeface="Noto Sans KR"/>
-                <a:ea typeface="Noto Sans KR"/>
-                <a:cs typeface="Noto Sans KR"/>
-              </a:defRPr>
-            </a:pPr>
-            <a:r>
-              <a:rPr sz="1400">
-                <a:solidFill>
-                  <a:srgbClr val="1E2A3A"/>
-                </a:solidFill>
-                <a:latin typeface="Malgun Gothic"/>
-                <a:ea typeface="Malgun Gothic"/>
-                <a:cs typeface="Malgun Gothic"/>
+              <a:defRPr sz="1350">
+                <a:solidFill>
+                  <a:srgbClr val="334155"/>
+                </a:solidFill>
+                <a:latin typeface="Noto Sans KR"/>
+                <a:ea typeface="Noto Sans KR"/>
+                <a:cs typeface="Noto Sans KR"/>
+              </a:defRPr>
+            </a:pPr>
+            <a:r>
+              <a:rPr sz="1350">
+                <a:solidFill>
+                  <a:srgbClr val="334155"/>
+                </a:solidFill>
+                <a:latin typeface="Noto Sans KR"/>
+                <a:ea typeface="Noto Sans KR"/>
+                <a:cs typeface="Noto Sans KR"/>
               </a:rPr>
               <a:t>원본 JSONB 보존 + 지표 버전 관리 — 공식이 바뀌면 재수집 없이 전체 재계산</a:t>
             </a:r>
@@ -8694,22 +8700,25 @@
                 <a:spcPts val="1000"/>
               </a:spcAft>
               <a:buChar char="•"/>
-              <a:defRPr>
-                <a:latin typeface="Noto Sans KR"/>
-                <a:ea typeface="Noto Sans KR"/>
-                <a:cs typeface="Noto Sans KR"/>
-              </a:defRPr>
-            </a:pPr>
-            <a:r>
-              <a:rPr sz="1400">
-                <a:solidFill>
-                  <a:srgbClr val="1E2A3A"/>
-                </a:solidFill>
-                <a:latin typeface="Malgun Gothic"/>
-                <a:ea typeface="Malgun Gothic"/>
-                <a:cs typeface="Malgun Gothic"/>
-              </a:rPr>
-              <a:t>Docker Compose 로컬 스택 (FastAPI · Next.js · PostgreSQL 16) — 테스트 223개 통과 유지</a:t>
+              <a:defRPr sz="1350">
+                <a:solidFill>
+                  <a:srgbClr val="334155"/>
+                </a:solidFill>
+                <a:latin typeface="Noto Sans KR"/>
+                <a:ea typeface="Noto Sans KR"/>
+                <a:cs typeface="Noto Sans KR"/>
+              </a:defRPr>
+            </a:pPr>
+            <a:r>
+              <a:rPr sz="1350">
+                <a:solidFill>
+                  <a:srgbClr val="334155"/>
+                </a:solidFill>
+                <a:latin typeface="Noto Sans KR"/>
+                <a:ea typeface="Noto Sans KR"/>
+                <a:cs typeface="Noto Sans KR"/>
+              </a:rPr>
+              <a:t>Docker Compose 로컬 스택 (FastAPI · Next.js · PostgreSQL 16) — 자동 회귀 테스트 통과 유지</a:t>
             </a:r>
           </a:p>
         </p:txBody>
@@ -10170,7 +10179,7 @@
                 <a:ea typeface="Noto Sans KR"/>
                 <a:cs typeface="Noto Sans KR"/>
               </a:rPr>
-              <a:t>+ 10분 라인 우세도 · 오브젝트 준비 · 리드 전환 · 변곡점 · 킬/데스 히트맵</a:t>
+              <a:t>+ 10분 자원 우세도 · 초반 교전 영향력 · 체력 압박 참고 신호</a:t>
             </a:r>
           </a:p>
           <a:p xmlns:a="http://schemas.openxmlformats.org/drawingml/2006/main">
@@ -10194,7 +10203,7 @@
                 <a:ea typeface="Noto Sans KR"/>
                 <a:cs typeface="Noto Sans KR"/>
               </a:rPr>
-              <a:t>퍼포먼스와 위험·스타일 신호를 분리해 보여줍니다</a:t>
+              <a:t>오브젝트 준비 · 리드 전환 · 변곡점 · 킬/데스 히트맵</a:t>
             </a:r>
           </a:p>
         </p:txBody>
@@ -10419,7 +10428,7 @@
           <p:nvPr/>
         </p:nvPicPr>
         <p:blipFill>
-          <a:blip xmlns:r="http://schemas.openxmlformats.org/officeDocument/2006/relationships" xmlns:a="http://schemas.openxmlformats.org/drawingml/2006/main" r:embed="R8a6fe00aaab04287"/>
+          <a:blip xmlns:r="http://schemas.openxmlformats.org/officeDocument/2006/relationships" xmlns:a="http://schemas.openxmlformats.org/drawingml/2006/main" r:embed="R71b70a0cc3e64191"/>
           <a:srcRect xmlns:a="http://schemas.openxmlformats.org/drawingml/2006/main" l="-25498" t="0" r="-25498" b="0"/>
           <a:stretch xmlns:a="http://schemas.openxmlformats.org/drawingml/2006/main"/>
         </p:blipFill>
@@ -10532,7 +10541,7 @@
           <p:nvPr/>
         </p:nvPicPr>
         <p:blipFill>
-          <a:blip xmlns:r="http://schemas.openxmlformats.org/officeDocument/2006/relationships" xmlns:a="http://schemas.openxmlformats.org/drawingml/2006/main" r:embed="R3fcd42e5750c4cd2"/>
+          <a:blip xmlns:r="http://schemas.openxmlformats.org/officeDocument/2006/relationships" xmlns:a="http://schemas.openxmlformats.org/drawingml/2006/main" r:embed="R7142ed8bd0a14628"/>
           <a:srcRect xmlns:a="http://schemas.openxmlformats.org/drawingml/2006/main" l="-25815" t="0" r="-25815" b="0"/>
           <a:stretch xmlns:a="http://schemas.openxmlformats.org/drawingml/2006/main"/>
         </p:blipFill>
@@ -12987,7 +12996,7 @@
           <p:nvPr/>
         </p:nvPicPr>
         <p:blipFill>
-          <a:blip xmlns:r="http://schemas.openxmlformats.org/officeDocument/2006/relationships" xmlns:a="http://schemas.openxmlformats.org/drawingml/2006/main" r:embed="R1c5f15dd86814e7a"/>
+          <a:blip xmlns:r="http://schemas.openxmlformats.org/officeDocument/2006/relationships" xmlns:a="http://schemas.openxmlformats.org/drawingml/2006/main" r:embed="R56a89b6799e940f7"/>
           <a:srcRect xmlns:a="http://schemas.openxmlformats.org/drawingml/2006/main" l="0" t="0" r="0" b="0"/>
           <a:stretch xmlns:a="http://schemas.openxmlformats.org/drawingml/2006/main"/>
         </p:blipFill>
@@ -13100,7 +13109,7 @@
           <p:nvPr/>
         </p:nvPicPr>
         <p:blipFill>
-          <a:blip xmlns:r="http://schemas.openxmlformats.org/officeDocument/2006/relationships" xmlns:a="http://schemas.openxmlformats.org/drawingml/2006/main" r:embed="Ree2f100a9e774afa"/>
+          <a:blip xmlns:r="http://schemas.openxmlformats.org/officeDocument/2006/relationships" xmlns:a="http://schemas.openxmlformats.org/drawingml/2006/main" r:embed="Raa6c91abe0074f24"/>
           <a:srcRect xmlns:a="http://schemas.openxmlformats.org/drawingml/2006/main" l="-25815" t="0" r="-25815" b="0"/>
           <a:stretch xmlns:a="http://schemas.openxmlformats.org/drawingml/2006/main"/>
         </p:blipFill>

</xml_diff>

<commit_message>
docs: clarify collector and analysis roadmap
</commit_message>
<xml_diff>
--- a/docs/presentation/LoL_AI_플랫폼_발표_2026-07-21_v5_모델_AI리포트.pptx
+++ b/docs/presentation/LoL_AI_플랫폼_발표_2026-07-21_v5_모델_AI리포트.pptx
@@ -2,24 +2,24 @@
 <file path=ppt/presentation.xml><?xml version="1.0" encoding="utf-8"?>
 <p:presentation xmlns:p="http://schemas.openxmlformats.org/presentationml/2006/main">
   <p:sldMasterIdLst>
-    <p:sldMasterId xmlns:r="http://schemas.openxmlformats.org/officeDocument/2006/relationships" id="2147483648" r:id="R2e62f45ec4df461d"/>
+    <p:sldMasterId xmlns:r="http://schemas.openxmlformats.org/officeDocument/2006/relationships" id="2147483648" r:id="Rb5d10aa094144443"/>
   </p:sldMasterIdLst>
   <p:notesMasterIdLst>
-    <p:notesMasterId xmlns:r="http://schemas.openxmlformats.org/officeDocument/2006/relationships" r:id="Rd3a77dffeb9e435a"/>
+    <p:notesMasterId xmlns:r="http://schemas.openxmlformats.org/officeDocument/2006/relationships" r:id="Rf70f586d29f8406e"/>
   </p:notesMasterIdLst>
   <p:sldIdLst>
-    <p:sldId xmlns:r="http://schemas.openxmlformats.org/officeDocument/2006/relationships" id="256" r:id="Re8098fcef1424134"/>
-    <p:sldId xmlns:r="http://schemas.openxmlformats.org/officeDocument/2006/relationships" id="257" r:id="Rbdb229e3bd234412"/>
-    <p:sldId xmlns:r="http://schemas.openxmlformats.org/officeDocument/2006/relationships" id="258" r:id="R4cf4df20fda8492b"/>
-    <p:sldId xmlns:r="http://schemas.openxmlformats.org/officeDocument/2006/relationships" id="259" r:id="Rc3240d0a66e841a9"/>
-    <p:sldId xmlns:r="http://schemas.openxmlformats.org/officeDocument/2006/relationships" id="260" r:id="R1b4a55b2408f4ed5"/>
-    <p:sldId xmlns:r="http://schemas.openxmlformats.org/officeDocument/2006/relationships" id="261" r:id="Rdb9eca84a8f14420"/>
-    <p:sldId xmlns:r="http://schemas.openxmlformats.org/officeDocument/2006/relationships" id="262" r:id="R96933e2aa2bc42bb"/>
-    <p:sldId xmlns:r="http://schemas.openxmlformats.org/officeDocument/2006/relationships" id="263" r:id="Rd5a1d13edae142fb"/>
-    <p:sldId xmlns:r="http://schemas.openxmlformats.org/officeDocument/2006/relationships" id="264" r:id="R8541684f9d534e20"/>
-    <p:sldId xmlns:r="http://schemas.openxmlformats.org/officeDocument/2006/relationships" id="265" r:id="R37c15ec0992343fc"/>
-    <p:sldId xmlns:r="http://schemas.openxmlformats.org/officeDocument/2006/relationships" id="266" r:id="R8c7a85192eca41aa"/>
-    <p:sldId xmlns:r="http://schemas.openxmlformats.org/officeDocument/2006/relationships" id="267" r:id="R338073d056b740fc"/>
+    <p:sldId xmlns:r="http://schemas.openxmlformats.org/officeDocument/2006/relationships" id="256" r:id="R803bfab017e5487b"/>
+    <p:sldId xmlns:r="http://schemas.openxmlformats.org/officeDocument/2006/relationships" id="257" r:id="Rf559ff600f4f4d89"/>
+    <p:sldId xmlns:r="http://schemas.openxmlformats.org/officeDocument/2006/relationships" id="258" r:id="Rd153555f75124874"/>
+    <p:sldId xmlns:r="http://schemas.openxmlformats.org/officeDocument/2006/relationships" id="259" r:id="R20bf89b588864262"/>
+    <p:sldId xmlns:r="http://schemas.openxmlformats.org/officeDocument/2006/relationships" id="260" r:id="R2addfee18d7d4885"/>
+    <p:sldId xmlns:r="http://schemas.openxmlformats.org/officeDocument/2006/relationships" id="261" r:id="R9e00b68a2b234b5a"/>
+    <p:sldId xmlns:r="http://schemas.openxmlformats.org/officeDocument/2006/relationships" id="262" r:id="Rbe0ecb6048964efe"/>
+    <p:sldId xmlns:r="http://schemas.openxmlformats.org/officeDocument/2006/relationships" id="263" r:id="R7b2eafa8b4e4402c"/>
+    <p:sldId xmlns:r="http://schemas.openxmlformats.org/officeDocument/2006/relationships" id="264" r:id="R7014cb35a65a45f6"/>
+    <p:sldId xmlns:r="http://schemas.openxmlformats.org/officeDocument/2006/relationships" id="265" r:id="Redc572e3ff5a49d1"/>
+    <p:sldId xmlns:r="http://schemas.openxmlformats.org/officeDocument/2006/relationships" id="266" r:id="R3940f254840f4e7c"/>
+    <p:sldId xmlns:r="http://schemas.openxmlformats.org/officeDocument/2006/relationships" id="267" r:id="Rc903bb5bd4644c9c"/>
   </p:sldIdLst>
   <p:sldSz cx="12192000" cy="6858000"/>
   <p:notesSz cx="6858000" cy="9144000"/>
@@ -1426,7 +1426,7 @@
   </p:cSld>
   <p:clrMap bg1="lt1" tx1="dk1" bg2="lt2" tx2="dk2" accent1="accent1" accent2="accent2" accent3="accent3" accent4="accent4" accent5="accent5" accent6="accent6" hlink="hlink" folHlink="folHlink"/>
   <p:sldLayoutIdLst>
-    <p:sldLayoutId xmlns:r="http://schemas.openxmlformats.org/officeDocument/2006/relationships" id="2147483649" r:id="R9be435eba1384e3e"/>
+    <p:sldLayoutId xmlns:r="http://schemas.openxmlformats.org/officeDocument/2006/relationships" id="2147483649" r:id="Rc013173813ec4c58"/>
   </p:sldLayoutIdLst>
   <p:hf sldNum="0" hdr="0" ftr="0" dt="0"/>
   <p:txStyles>
@@ -3960,7 +3960,7 @@
         </p:xfrm>
         <a:graphic xmlns:a="http://schemas.openxmlformats.org/drawingml/2006/main">
           <a:graphicData uri="http://schemas.openxmlformats.org/drawingml/2006/chart">
-            <c:chart xmlns:r="http://schemas.openxmlformats.org/officeDocument/2006/relationships" xmlns:c="http://schemas.openxmlformats.org/drawingml/2006/chart" r:id="R6433edea35094931"/>
+            <c:chart xmlns:r="http://schemas.openxmlformats.org/officeDocument/2006/relationships" xmlns:c="http://schemas.openxmlformats.org/drawingml/2006/chart" r:id="Rc1d2e7a759a1410c"/>
           </a:graphicData>
         </a:graphic>
       </p:graphicFrame>
@@ -4023,22 +4023,25 @@
           <a:p xmlns:a="http://schemas.openxmlformats.org/drawingml/2006/main">
             <a:pPr marL="0" indent="0">
               <a:buNone/>
-              <a:defRPr sz="1350">
-                <a:latin typeface="Noto Sans KR"/>
-                <a:ea typeface="Noto Sans KR"/>
-                <a:cs typeface="Noto Sans KR"/>
-              </a:defRPr>
-            </a:pPr>
-            <a:r>
-              <a:rPr sz="1300" b="1" spc="200">
-                <a:solidFill>
-                  <a:srgbClr val="C89B3C"/>
-                </a:solidFill>
-                <a:latin typeface="Malgun Gothic"/>
-                <a:ea typeface="Malgun Gothic"/>
-                <a:cs typeface="Malgun Gothic"/>
-              </a:rPr>
-              <a:t>NEW</a:t>
+              <a:defRPr sz="1350" b="1">
+                <a:solidFill>
+                  <a:srgbClr val="D29B2E"/>
+                </a:solidFill>
+                <a:latin typeface="Noto Sans KR"/>
+                <a:ea typeface="Noto Sans KR"/>
+                <a:cs typeface="Noto Sans KR"/>
+              </a:defRPr>
+            </a:pPr>
+            <a:r>
+              <a:rPr sz="1350" b="1">
+                <a:solidFill>
+                  <a:srgbClr val="D29B2E"/>
+                </a:solidFill>
+                <a:latin typeface="Noto Sans KR"/>
+                <a:ea typeface="Noto Sans KR"/>
+                <a:cs typeface="Noto Sans KR"/>
+              </a:rPr>
+              <a:t>확장 기능</a:t>
             </a:r>
           </a:p>
         </p:txBody>
@@ -4073,22 +4076,25 @@
           <a:p xmlns:a="http://schemas.openxmlformats.org/drawingml/2006/main">
             <a:pPr marL="0" indent="0">
               <a:buNone/>
-              <a:defRPr>
-                <a:latin typeface="Noto Sans KR"/>
-                <a:ea typeface="Noto Sans KR"/>
-                <a:cs typeface="Noto Sans KR"/>
-              </a:defRPr>
-            </a:pPr>
-            <a:r>
-              <a:rPr sz="3000" b="1">
+              <a:defRPr sz="3150" b="1">
                 <a:solidFill>
                   <a:srgbClr val="1E2A3A"/>
                 </a:solidFill>
-                <a:latin typeface="Malgun Gothic"/>
-                <a:ea typeface="Malgun Gothic"/>
-                <a:cs typeface="Malgun Gothic"/>
-              </a:rPr>
-              <a:t>Live Client 컴패니언 — 내 게임을 실시간 수집</a:t>
+                <a:latin typeface="Noto Sans KR"/>
+                <a:ea typeface="Noto Sans KR"/>
+                <a:cs typeface="Noto Sans KR"/>
+              </a:defRPr>
+            </a:pPr>
+            <a:r>
+              <a:rPr sz="3150" b="1">
+                <a:solidFill>
+                  <a:srgbClr val="1E2A3A"/>
+                </a:solidFill>
+                <a:latin typeface="Noto Sans KR"/>
+                <a:ea typeface="Noto Sans KR"/>
+                <a:cs typeface="Noto Sans KR"/>
+              </a:rPr>
+              <a:t>선택형 로컬 수집 — 경기 후 분석을 더 세밀하게</a:t>
             </a:r>
           </a:p>
         </p:txBody>
@@ -4255,43 +4261,49 @@
           <a:p xmlns:a="http://schemas.openxmlformats.org/drawingml/2006/main">
             <a:pPr marL="0" indent="0" algn="ctr">
               <a:buNone/>
-              <a:defRPr>
-                <a:latin typeface="Noto Sans KR"/>
-                <a:ea typeface="Noto Sans KR"/>
-                <a:cs typeface="Noto Sans KR"/>
-              </a:defRPr>
-            </a:pPr>
-            <a:r>
-              <a:rPr sz="1150">
+              <a:defRPr sz="1275">
                 <a:solidFill>
                   <a:srgbClr val="E8EEF6"/>
                 </a:solidFill>
-                <a:latin typeface="Malgun Gothic"/>
-                <a:ea typeface="Malgun Gothic"/>
-                <a:cs typeface="Malgun Gothic"/>
-              </a:rPr>
-              <a:t>로컬 Live Client</a:t>
+                <a:latin typeface="Noto Sans KR"/>
+                <a:ea typeface="Noto Sans KR"/>
+                <a:cs typeface="Noto Sans KR"/>
+              </a:defRPr>
+            </a:pPr>
+            <a:r>
+              <a:rPr sz="1275">
+                <a:solidFill>
+                  <a:srgbClr val="E8EEF6"/>
+                </a:solidFill>
+                <a:latin typeface="Noto Sans KR"/>
+                <a:ea typeface="Noto Sans KR"/>
+                <a:cs typeface="Noto Sans KR"/>
+              </a:rPr>
+              <a:t>게임 시작을 감지하고</a:t>
             </a:r>
           </a:p>
           <a:p xmlns:a="http://schemas.openxmlformats.org/drawingml/2006/main">
             <a:pPr marL="0" indent="0" algn="ctr">
               <a:buNone/>
-              <a:defRPr>
-                <a:latin typeface="Noto Sans KR"/>
-                <a:ea typeface="Noto Sans KR"/>
-                <a:cs typeface="Noto Sans KR"/>
-              </a:defRPr>
-            </a:pPr>
-            <a:r>
-              <a:rPr sz="1150">
+              <a:defRPr sz="1275">
                 <a:solidFill>
                   <a:srgbClr val="E8EEF6"/>
                 </a:solidFill>
-                <a:latin typeface="Malgun Gothic"/>
-                <a:ea typeface="Malgun Gothic"/>
-                <a:cs typeface="Malgun Gothic"/>
-              </a:rPr>
-              <a:t>API 폴링 (1초)</a:t>
+                <a:latin typeface="Noto Sans KR"/>
+                <a:ea typeface="Noto Sans KR"/>
+                <a:cs typeface="Noto Sans KR"/>
+              </a:defRPr>
+            </a:pPr>
+            <a:r>
+              <a:rPr sz="1275">
+                <a:solidFill>
+                  <a:srgbClr val="E8EEF6"/>
+                </a:solidFill>
+                <a:latin typeface="Noto Sans KR"/>
+                <a:ea typeface="Noto Sans KR"/>
+                <a:cs typeface="Noto Sans KR"/>
+              </a:rPr>
+              <a:t>1초마다 상태를 확인</a:t>
             </a:r>
           </a:p>
         </p:txBody>
@@ -4466,43 +4478,49 @@
           <a:p xmlns:a="http://schemas.openxmlformats.org/drawingml/2006/main">
             <a:pPr marL="0" indent="0" algn="ctr">
               <a:buNone/>
-              <a:defRPr>
-                <a:latin typeface="Noto Sans KR"/>
-                <a:ea typeface="Noto Sans KR"/>
-                <a:cs typeface="Noto Sans KR"/>
-              </a:defRPr>
-            </a:pPr>
-            <a:r>
-              <a:rPr sz="1150">
+              <a:defRPr sz="1275">
                 <a:solidFill>
                   <a:srgbClr val="E8EEF6"/>
                 </a:solidFill>
-                <a:latin typeface="Malgun Gothic"/>
-                <a:ea typeface="Malgun Gothic"/>
-                <a:cs typeface="Malgun Gothic"/>
-              </a:rPr>
-              <a:t>SQLite 큐</a:t>
+                <a:latin typeface="Noto Sans KR"/>
+                <a:ea typeface="Noto Sans KR"/>
+                <a:cs typeface="Noto Sans KR"/>
+              </a:defRPr>
+            </a:pPr>
+            <a:r>
+              <a:rPr sz="1275">
+                <a:solidFill>
+                  <a:srgbClr val="E8EEF6"/>
+                </a:solidFill>
+                <a:latin typeface="Noto Sans KR"/>
+                <a:ea typeface="Noto Sans KR"/>
+                <a:cs typeface="Noto Sans KR"/>
+              </a:rPr>
+              <a:t>체력·골드·이벤트를</a:t>
             </a:r>
           </a:p>
           <a:p xmlns:a="http://schemas.openxmlformats.org/drawingml/2006/main">
             <a:pPr marL="0" indent="0" algn="ctr">
               <a:buNone/>
-              <a:defRPr>
-                <a:latin typeface="Noto Sans KR"/>
-                <a:ea typeface="Noto Sans KR"/>
-                <a:cs typeface="Noto Sans KR"/>
-              </a:defRPr>
-            </a:pPr>
-            <a:r>
-              <a:rPr sz="1150">
+              <a:defRPr sz="1275">
                 <a:solidFill>
                   <a:srgbClr val="E8EEF6"/>
                 </a:solidFill>
-                <a:latin typeface="Malgun Gothic"/>
-                <a:ea typeface="Malgun Gothic"/>
-                <a:cs typeface="Malgun Gothic"/>
-              </a:rPr>
-              <a:t>체력·골드·이벤트</a:t>
+                <a:latin typeface="Noto Sans KR"/>
+                <a:ea typeface="Noto Sans KR"/>
+                <a:cs typeface="Noto Sans KR"/>
+              </a:defRPr>
+            </a:pPr>
+            <a:r>
+              <a:rPr sz="1275">
+                <a:solidFill>
+                  <a:srgbClr val="E8EEF6"/>
+                </a:solidFill>
+                <a:latin typeface="Noto Sans KR"/>
+                <a:ea typeface="Noto Sans KR"/>
+                <a:cs typeface="Noto Sans KR"/>
+              </a:rPr>
+              <a:t>내 PC에 임시 저장</a:t>
             </a:r>
           </a:p>
         </p:txBody>
@@ -4677,43 +4695,49 @@
           <a:p xmlns:a="http://schemas.openxmlformats.org/drawingml/2006/main">
             <a:pPr marL="0" indent="0" algn="ctr">
               <a:buNone/>
-              <a:defRPr>
-                <a:latin typeface="Noto Sans KR"/>
-                <a:ea typeface="Noto Sans KR"/>
-                <a:cs typeface="Noto Sans KR"/>
-              </a:defRPr>
-            </a:pPr>
-            <a:r>
-              <a:rPr sz="1150">
+              <a:defRPr sz="1275">
                 <a:solidFill>
                   <a:srgbClr val="E8EEF6"/>
                 </a:solidFill>
-                <a:latin typeface="Malgun Gothic"/>
-                <a:ea typeface="Malgun Gothic"/>
-                <a:cs typeface="Malgun Gothic"/>
-              </a:rPr>
-              <a:t>재시도 안전</a:t>
+                <a:latin typeface="Noto Sans KR"/>
+                <a:ea typeface="Noto Sans KR"/>
+                <a:cs typeface="Noto Sans KR"/>
+              </a:defRPr>
+            </a:pPr>
+            <a:r>
+              <a:rPr sz="1275">
+                <a:solidFill>
+                  <a:srgbClr val="E8EEF6"/>
+                </a:solidFill>
+                <a:latin typeface="Noto Sans KR"/>
+                <a:ea typeface="Noto Sans KR"/>
+                <a:cs typeface="Noto Sans KR"/>
+              </a:rPr>
+              <a:t>전송이 끊겨도 이어서 업로드</a:t>
             </a:r>
           </a:p>
           <a:p xmlns:a="http://schemas.openxmlformats.org/drawingml/2006/main">
             <a:pPr marL="0" indent="0" algn="ctr">
               <a:buNone/>
-              <a:defRPr>
-                <a:latin typeface="Noto Sans KR"/>
-                <a:ea typeface="Noto Sans KR"/>
-                <a:cs typeface="Noto Sans KR"/>
-              </a:defRPr>
-            </a:pPr>
-            <a:r>
-              <a:rPr sz="1150">
+              <a:defRPr sz="1275">
                 <a:solidFill>
                   <a:srgbClr val="E8EEF6"/>
                 </a:solidFill>
-                <a:latin typeface="Malgun Gothic"/>
-                <a:ea typeface="Malgun Gothic"/>
-                <a:cs typeface="Malgun Gothic"/>
-              </a:rPr>
-              <a:t>(멱등 업로드)</a:t>
+                <a:latin typeface="Noto Sans KR"/>
+                <a:ea typeface="Noto Sans KR"/>
+                <a:cs typeface="Noto Sans KR"/>
+              </a:defRPr>
+            </a:pPr>
+            <a:r>
+              <a:rPr sz="1275">
+                <a:solidFill>
+                  <a:srgbClr val="E8EEF6"/>
+                </a:solidFill>
+                <a:latin typeface="Noto Sans KR"/>
+                <a:ea typeface="Noto Sans KR"/>
+                <a:cs typeface="Noto Sans KR"/>
+              </a:rPr>
+              <a:t>같은 경기는 중복 저장하지 않음</a:t>
             </a:r>
           </a:p>
         </p:txBody>
@@ -4888,43 +4912,49 @@
           <a:p xmlns:a="http://schemas.openxmlformats.org/drawingml/2006/main">
             <a:pPr marL="0" indent="0" algn="ctr">
               <a:buNone/>
-              <a:defRPr>
-                <a:latin typeface="Noto Sans KR"/>
-                <a:ea typeface="Noto Sans KR"/>
-                <a:cs typeface="Noto Sans KR"/>
-              </a:defRPr>
-            </a:pPr>
-            <a:r>
-              <a:rPr sz="1150">
-                <a:solidFill>
-                  <a:srgbClr val="E8EEF6"/>
-                </a:solidFill>
-                <a:latin typeface="Malgun Gothic"/>
-                <a:ea typeface="Malgun Gothic"/>
-                <a:cs typeface="Malgun Gothic"/>
-              </a:rPr>
-              <a:t>riot id + 시작 시각으로</a:t>
+              <a:defRPr sz="1275">
+                <a:solidFill>
+                  <a:srgbClr val="FFFFFF"/>
+                </a:solidFill>
+                <a:latin typeface="Noto Sans KR"/>
+                <a:ea typeface="Noto Sans KR"/>
+                <a:cs typeface="Noto Sans KR"/>
+              </a:defRPr>
+            </a:pPr>
+            <a:r>
+              <a:rPr sz="1275">
+                <a:solidFill>
+                  <a:srgbClr val="FFFFFF"/>
+                </a:solidFill>
+                <a:latin typeface="Noto Sans KR"/>
+                <a:ea typeface="Noto Sans KR"/>
+                <a:cs typeface="Noto Sans KR"/>
+              </a:rPr>
+              <a:t>Riot ID와 시작 시각으로</a:t>
             </a:r>
           </a:p>
           <a:p xmlns:a="http://schemas.openxmlformats.org/drawingml/2006/main">
             <a:pPr marL="0" indent="0" algn="ctr">
               <a:buNone/>
-              <a:defRPr>
-                <a:latin typeface="Noto Sans KR"/>
-                <a:ea typeface="Noto Sans KR"/>
-                <a:cs typeface="Noto Sans KR"/>
-              </a:defRPr>
-            </a:pPr>
-            <a:r>
-              <a:rPr sz="1150">
-                <a:solidFill>
-                  <a:srgbClr val="E8EEF6"/>
-                </a:solidFill>
-                <a:latin typeface="Malgun Gothic"/>
-                <a:ea typeface="Malgun Gothic"/>
-                <a:cs typeface="Malgun Gothic"/>
-              </a:rPr>
-              <a:t>저장된 경기와 자동 연결</a:t>
+              <a:defRPr sz="1275">
+                <a:solidFill>
+                  <a:srgbClr val="FFFFFF"/>
+                </a:solidFill>
+                <a:latin typeface="Noto Sans KR"/>
+                <a:ea typeface="Noto Sans KR"/>
+                <a:cs typeface="Noto Sans KR"/>
+              </a:defRPr>
+            </a:pPr>
+            <a:r>
+              <a:rPr sz="1275">
+                <a:solidFill>
+                  <a:srgbClr val="FFFFFF"/>
+                </a:solidFill>
+                <a:latin typeface="Noto Sans KR"/>
+                <a:ea typeface="Noto Sans KR"/>
+                <a:cs typeface="Noto Sans KR"/>
+              </a:rPr>
+              <a:t>내 전적에 자동 연결</a:t>
             </a:r>
           </a:p>
         </p:txBody>
@@ -4999,22 +5029,25 @@
           <a:p xmlns:a="http://schemas.openxmlformats.org/drawingml/2006/main">
             <a:pPr marL="0" indent="0">
               <a:buNone/>
-              <a:defRPr>
-                <a:latin typeface="Noto Sans KR"/>
-                <a:ea typeface="Noto Sans KR"/>
-                <a:cs typeface="Noto Sans KR"/>
-              </a:defRPr>
-            </a:pPr>
-            <a:r>
-              <a:rPr sz="1400" b="1">
+              <a:defRPr sz="1425" b="1">
                 <a:solidFill>
                   <a:srgbClr val="0B7A70"/>
                 </a:solidFill>
-                <a:latin typeface="Malgun Gothic"/>
-                <a:ea typeface="Malgun Gothic"/>
-                <a:cs typeface="Malgun Gothic"/>
-              </a:rPr>
-              <a:t>수집 전용 · Opt-in</a:t>
+                <a:latin typeface="Noto Sans KR"/>
+                <a:ea typeface="Noto Sans KR"/>
+                <a:cs typeface="Noto Sans KR"/>
+              </a:defRPr>
+            </a:pPr>
+            <a:r>
+              <a:rPr sz="1425" b="1">
+                <a:solidFill>
+                  <a:srgbClr val="0B7A70"/>
+                </a:solidFill>
+                <a:latin typeface="Noto Sans KR"/>
+                <a:ea typeface="Noto Sans KR"/>
+                <a:cs typeface="Noto Sans KR"/>
+              </a:rPr>
+              <a:t>사용자가 직접 켜는 선택 수집</a:t>
             </a:r>
           </a:p>
         </p:txBody>
@@ -5049,22 +5082,25 @@
           <a:p xmlns:a="http://schemas.openxmlformats.org/drawingml/2006/main">
             <a:pPr marL="0" indent="0">
               <a:buNone/>
-              <a:defRPr>
-                <a:latin typeface="Noto Sans KR"/>
-                <a:ea typeface="Noto Sans KR"/>
-                <a:cs typeface="Noto Sans KR"/>
-              </a:defRPr>
-            </a:pPr>
-            <a:r>
-              <a:rPr sz="1250">
-                <a:solidFill>
-                  <a:srgbClr val="1E2A3A"/>
-                </a:solidFill>
-                <a:latin typeface="Malgun Gothic"/>
-                <a:ea typeface="Malgun Gothic"/>
-                <a:cs typeface="Malgun Gothic"/>
-              </a:rPr>
-              <a:t>경기 중 어떤 분석·조언도 표시하지 않음 (정책 준수) — 본인 게임만 수집</a:t>
+              <a:defRPr sz="1275">
+                <a:solidFill>
+                  <a:srgbClr val="334155"/>
+                </a:solidFill>
+                <a:latin typeface="Noto Sans KR"/>
+                <a:ea typeface="Noto Sans KR"/>
+                <a:cs typeface="Noto Sans KR"/>
+              </a:defRPr>
+            </a:pPr>
+            <a:r>
+              <a:rPr sz="1275">
+                <a:solidFill>
+                  <a:srgbClr val="334155"/>
+                </a:solidFill>
+                <a:latin typeface="Noto Sans KR"/>
+                <a:ea typeface="Noto Sans KR"/>
+                <a:cs typeface="Noto Sans KR"/>
+              </a:rPr>
+              <a:t>경기 중에는 분석·조언을 표시하지 않고, 본인 게임만 수집</a:t>
             </a:r>
           </a:p>
         </p:txBody>
@@ -5139,22 +5175,25 @@
           <a:p xmlns:a="http://schemas.openxmlformats.org/drawingml/2006/main">
             <a:pPr marL="0" indent="0">
               <a:buNone/>
-              <a:defRPr>
-                <a:latin typeface="Noto Sans KR"/>
-                <a:ea typeface="Noto Sans KR"/>
-                <a:cs typeface="Noto Sans KR"/>
-              </a:defRPr>
-            </a:pPr>
-            <a:r>
-              <a:rPr sz="1400" b="1">
+              <a:defRPr sz="1425" b="1">
                 <a:solidFill>
                   <a:srgbClr val="0B7A70"/>
                 </a:solidFill>
-                <a:latin typeface="Malgun Gothic"/>
-                <a:ea typeface="Malgun Gothic"/>
-                <a:cs typeface="Malgun Gothic"/>
-              </a:rPr>
-              <a:t>Riot API에 없는 데이터</a:t>
+                <a:latin typeface="Noto Sans KR"/>
+                <a:ea typeface="Noto Sans KR"/>
+                <a:cs typeface="Noto Sans KR"/>
+              </a:defRPr>
+            </a:pPr>
+            <a:r>
+              <a:rPr sz="1425" b="1">
+                <a:solidFill>
+                  <a:srgbClr val="0B7A70"/>
+                </a:solidFill>
+                <a:latin typeface="Noto Sans KR"/>
+                <a:ea typeface="Noto Sans KR"/>
+                <a:cs typeface="Noto Sans KR"/>
+              </a:rPr>
+              <a:t>분석 근거 보강</a:t>
             </a:r>
           </a:p>
         </p:txBody>
@@ -5189,22 +5228,25 @@
           <a:p xmlns:a="http://schemas.openxmlformats.org/drawingml/2006/main">
             <a:pPr marL="0" indent="0">
               <a:buNone/>
-              <a:defRPr>
-                <a:latin typeface="Noto Sans KR"/>
-                <a:ea typeface="Noto Sans KR"/>
-                <a:cs typeface="Noto Sans KR"/>
-              </a:defRPr>
-            </a:pPr>
-            <a:r>
-              <a:rPr sz="1250">
-                <a:solidFill>
-                  <a:srgbClr val="1E2A3A"/>
-                </a:solidFill>
-                <a:latin typeface="Malgun Gothic"/>
-                <a:ea typeface="Malgun Gothic"/>
-                <a:cs typeface="Malgun Gothic"/>
-              </a:rPr>
-              <a:t>초단위 내 체력·골드·스탯 — 체력 기반 위험 판단, 틸트 신호 정밀화의 재료</a:t>
+              <a:defRPr sz="1275">
+                <a:solidFill>
+                  <a:srgbClr val="334155"/>
+                </a:solidFill>
+                <a:latin typeface="Noto Sans KR"/>
+                <a:ea typeface="Noto Sans KR"/>
+                <a:cs typeface="Noto Sans KR"/>
+              </a:defRPr>
+            </a:pPr>
+            <a:r>
+              <a:rPr sz="1275">
+                <a:solidFill>
+                  <a:srgbClr val="334155"/>
+                </a:solidFill>
+                <a:latin typeface="Noto Sans KR"/>
+                <a:ea typeface="Noto Sans KR"/>
+                <a:cs typeface="Noto Sans KR"/>
+              </a:rPr>
+              <a:t>초 단위 체력·골드 변화로 위험 구간과 사망 전후 흐름을 더 세밀하게 복기</a:t>
             </a:r>
           </a:p>
         </p:txBody>
@@ -5279,22 +5321,25 @@
           <a:p xmlns:a="http://schemas.openxmlformats.org/drawingml/2006/main">
             <a:pPr marL="0" indent="0">
               <a:buNone/>
-              <a:defRPr>
-                <a:latin typeface="Noto Sans KR"/>
-                <a:ea typeface="Noto Sans KR"/>
-                <a:cs typeface="Noto Sans KR"/>
-              </a:defRPr>
-            </a:pPr>
-            <a:r>
-              <a:rPr sz="1400" b="1">
+              <a:defRPr sz="1425" b="1">
                 <a:solidFill>
                   <a:srgbClr val="0B7A70"/>
                 </a:solidFill>
-                <a:latin typeface="Malgun Gothic"/>
-                <a:ea typeface="Malgun Gothic"/>
-                <a:cs typeface="Malgun Gothic"/>
-              </a:rPr>
-              <a:t>설치형</a:t>
+                <a:latin typeface="Noto Sans KR"/>
+                <a:ea typeface="Noto Sans KR"/>
+                <a:cs typeface="Noto Sans KR"/>
+              </a:defRPr>
+            </a:pPr>
+            <a:r>
+              <a:rPr sz="1425" b="1">
+                <a:solidFill>
+                  <a:srgbClr val="0B7A70"/>
+                </a:solidFill>
+                <a:latin typeface="Noto Sans KR"/>
+                <a:ea typeface="Noto Sans KR"/>
+                <a:cs typeface="Noto Sans KR"/>
+              </a:rPr>
+              <a:t>가볍게 실행</a:t>
             </a:r>
           </a:p>
         </p:txBody>
@@ -5329,22 +5374,25 @@
           <a:p xmlns:a="http://schemas.openxmlformats.org/drawingml/2006/main">
             <a:pPr marL="0" indent="0">
               <a:buNone/>
-              <a:defRPr>
-                <a:latin typeface="Noto Sans KR"/>
-                <a:ea typeface="Noto Sans KR"/>
-                <a:cs typeface="Noto Sans KR"/>
-              </a:defRPr>
-            </a:pPr>
-            <a:r>
-              <a:rPr sz="1250">
-                <a:solidFill>
-                  <a:srgbClr val="1E2A3A"/>
-                </a:solidFill>
-                <a:latin typeface="Malgun Gothic"/>
-                <a:ea typeface="Malgun Gothic"/>
-                <a:cs typeface="Malgun Gothic"/>
-              </a:rPr>
-              <a:t>Python 표준 라이브러리만 사용한 단일 파일 — 게임 PC에서 바로 실행</a:t>
+              <a:defRPr sz="1275">
+                <a:solidFill>
+                  <a:srgbClr val="334155"/>
+                </a:solidFill>
+                <a:latin typeface="Noto Sans KR"/>
+                <a:ea typeface="Noto Sans KR"/>
+                <a:cs typeface="Noto Sans KR"/>
+              </a:defRPr>
+            </a:pPr>
+            <a:r>
+              <a:rPr sz="1275">
+                <a:solidFill>
+                  <a:srgbClr val="334155"/>
+                </a:solidFill>
+                <a:latin typeface="Noto Sans KR"/>
+                <a:ea typeface="Noto Sans KR"/>
+                <a:cs typeface="Noto Sans KR"/>
+              </a:rPr>
+              <a:t>게임 PC에서 실행하는 가벼운 단일 프로그램</a:t>
             </a:r>
           </a:p>
         </p:txBody>
@@ -5694,7 +5742,7 @@
                 <a:ea typeface="Noto Sans KR"/>
                 <a:cs typeface="Noto Sans KR"/>
               </a:rPr>
-              <a:t>분당 승률 모델 고도화</a:t>
+              <a:t>역할별 플레이 분석 확장</a:t>
             </a:r>
           </a:p>
         </p:txBody>
@@ -5747,7 +5795,7 @@
                 <a:ea typeface="Noto Sans KR"/>
                 <a:cs typeface="Noto Sans KR"/>
               </a:rPr>
-              <a:t>시간별 경기 상태로 승률을 예측하고, 검증 기준을 통과한 모델만 교체</a:t>
+              <a:t>탑·정글·미드·원딜·서포터마다 다른 역할과 판단 기준으로 지표를 분리</a:t>
             </a:r>
           </a:p>
         </p:txBody>
@@ -5870,22 +5918,25 @@
           <a:p xmlns:a="http://schemas.openxmlformats.org/drawingml/2006/main">
             <a:pPr marL="0" indent="0">
               <a:buNone/>
-              <a:defRPr>
-                <a:latin typeface="Noto Sans KR"/>
-                <a:ea typeface="Noto Sans KR"/>
-                <a:cs typeface="Noto Sans KR"/>
-              </a:defRPr>
-            </a:pPr>
-            <a:r>
-              <a:rPr sz="1650" b="1">
+              <a:defRPr sz="1800" b="1">
                 <a:solidFill>
                   <a:srgbClr val="FFFFFF"/>
                 </a:solidFill>
-                <a:latin typeface="Malgun Gothic"/>
-                <a:ea typeface="Malgun Gothic"/>
-                <a:cs typeface="Malgun Gothic"/>
-              </a:rPr>
-              <a:t>티어 라벨 코호트</a:t>
+                <a:latin typeface="Noto Sans KR"/>
+                <a:ea typeface="Noto Sans KR"/>
+                <a:cs typeface="Noto Sans KR"/>
+              </a:defRPr>
+            </a:pPr>
+            <a:r>
+              <a:rPr sz="1800" b="1">
+                <a:solidFill>
+                  <a:srgbClr val="FFFFFF"/>
+                </a:solidFill>
+                <a:latin typeface="Noto Sans KR"/>
+                <a:ea typeface="Noto Sans KR"/>
+                <a:cs typeface="Noto Sans KR"/>
+              </a:rPr>
+              <a:t>지표 신뢰도 높이기</a:t>
             </a:r>
           </a:p>
         </p:txBody>
@@ -5920,22 +5971,25 @@
           <a:p xmlns:a="http://schemas.openxmlformats.org/drawingml/2006/main">
             <a:pPr marL="0" indent="0">
               <a:buNone/>
-              <a:defRPr>
-                <a:latin typeface="Noto Sans KR"/>
-                <a:ea typeface="Noto Sans KR"/>
-                <a:cs typeface="Noto Sans KR"/>
-              </a:defRPr>
-            </a:pPr>
-            <a:r>
-              <a:rPr sz="1250">
-                <a:solidFill>
-                  <a:srgbClr val="AEBDD0"/>
-                </a:solidFill>
-                <a:latin typeface="Malgun Gothic"/>
-                <a:ea typeface="Malgun Gothic"/>
-                <a:cs typeface="Malgun Gothic"/>
-              </a:rPr>
-              <a:t>수집 시 티어 스냅샷 저장 → 프로필 퍼센타일이 티어 기준으로</a:t>
+              <a:defRPr sz="1350">
+                <a:solidFill>
+                  <a:srgbClr val="B8C4D1"/>
+                </a:solidFill>
+                <a:latin typeface="Noto Sans KR"/>
+                <a:ea typeface="Noto Sans KR"/>
+                <a:cs typeface="Noto Sans KR"/>
+              </a:defRPr>
+            </a:pPr>
+            <a:r>
+              <a:rPr sz="1350">
+                <a:solidFill>
+                  <a:srgbClr val="B8C4D1"/>
+                </a:solidFill>
+                <a:latin typeface="Noto Sans KR"/>
+                <a:ea typeface="Noto Sans KR"/>
+                <a:cs typeface="Noto Sans KR"/>
+              </a:rPr>
+              <a:t>패치·티어·챔피언 상성별 기준값을 쌓고, 리플레이 검증으로 점수와 신뢰도를 보정</a:t>
             </a:r>
           </a:p>
         </p:txBody>
@@ -6058,22 +6112,25 @@
           <a:p xmlns:a="http://schemas.openxmlformats.org/drawingml/2006/main">
             <a:pPr marL="0" indent="0">
               <a:buNone/>
-              <a:defRPr>
-                <a:latin typeface="Noto Sans KR"/>
-                <a:ea typeface="Noto Sans KR"/>
-                <a:cs typeface="Noto Sans KR"/>
-              </a:defRPr>
-            </a:pPr>
-            <a:r>
-              <a:rPr sz="1650" b="1">
+              <a:defRPr sz="1800" b="1">
                 <a:solidFill>
                   <a:srgbClr val="FFFFFF"/>
                 </a:solidFill>
-                <a:latin typeface="Malgun Gothic"/>
-                <a:ea typeface="Malgun Gothic"/>
-                <a:cs typeface="Malgun Gothic"/>
-              </a:rPr>
-              <a:t>리플레이 분석기 (C2)</a:t>
+                <a:latin typeface="Noto Sans KR"/>
+                <a:ea typeface="Noto Sans KR"/>
+                <a:cs typeface="Noto Sans KR"/>
+              </a:defRPr>
+            </a:pPr>
+            <a:r>
+              <a:rPr sz="1800" b="1">
+                <a:solidFill>
+                  <a:srgbClr val="FFFFFF"/>
+                </a:solidFill>
+                <a:latin typeface="Noto Sans KR"/>
+                <a:ea typeface="Noto Sans KR"/>
+                <a:cs typeface="Noto Sans KR"/>
+              </a:rPr>
+              <a:t>분당 승률 모델 개선</a:t>
             </a:r>
           </a:p>
         </p:txBody>
@@ -6108,22 +6165,25 @@
           <a:p xmlns:a="http://schemas.openxmlformats.org/drawingml/2006/main">
             <a:pPr marL="0" indent="0">
               <a:buNone/>
-              <a:defRPr>
-                <a:latin typeface="Noto Sans KR"/>
-                <a:ea typeface="Noto Sans KR"/>
-                <a:cs typeface="Noto Sans KR"/>
-              </a:defRPr>
-            </a:pPr>
-            <a:r>
-              <a:rPr sz="1250">
-                <a:solidFill>
-                  <a:srgbClr val="AEBDD0"/>
-                </a:solidFill>
-                <a:latin typeface="Malgun Gothic"/>
-                <a:ea typeface="Malgun Gothic"/>
-                <a:cs typeface="Malgun Gothic"/>
-              </a:rPr>
-              <a:t>리플레이 미니맵 CV → 10인 좌표·시야 실측 — '피할 수 있던 데스' 판정</a:t>
+              <a:defRPr sz="1350">
+                <a:solidFill>
+                  <a:srgbClr val="B8C4D1"/>
+                </a:solidFill>
+                <a:latin typeface="Noto Sans KR"/>
+                <a:ea typeface="Noto Sans KR"/>
+                <a:cs typeface="Noto Sans KR"/>
+              </a:defRPr>
+            </a:pPr>
+            <a:r>
+              <a:rPr sz="1350">
+                <a:solidFill>
+                  <a:srgbClr val="B8C4D1"/>
+                </a:solidFill>
+                <a:latin typeface="Noto Sans KR"/>
+                <a:ea typeface="Noto Sans KR"/>
+                <a:cs typeface="Noto Sans KR"/>
+              </a:rPr>
+              <a:t>더 다양한 경기로 학습하고, 검증 기준을 통과한 모델만 서비스에 반영</a:t>
             </a:r>
           </a:p>
         </p:txBody>
@@ -6246,22 +6306,25 @@
           <a:p xmlns:a="http://schemas.openxmlformats.org/drawingml/2006/main">
             <a:pPr marL="0" indent="0">
               <a:buNone/>
-              <a:defRPr>
-                <a:latin typeface="Noto Sans KR"/>
-                <a:ea typeface="Noto Sans KR"/>
-                <a:cs typeface="Noto Sans KR"/>
-              </a:defRPr>
-            </a:pPr>
-            <a:r>
-              <a:rPr sz="1650" b="1">
+              <a:defRPr sz="1800" b="1">
                 <a:solidFill>
                   <a:srgbClr val="FFFFFF"/>
                 </a:solidFill>
-                <a:latin typeface="Malgun Gothic"/>
-                <a:ea typeface="Malgun Gothic"/>
-                <a:cs typeface="Malgun Gothic"/>
-              </a:rPr>
-              <a:t>하이라이트 &amp; 리플레이 시어터 (C3)</a:t>
+                <a:latin typeface="Noto Sans KR"/>
+                <a:ea typeface="Noto Sans KR"/>
+                <a:cs typeface="Noto Sans KR"/>
+              </a:defRPr>
+            </a:pPr>
+            <a:r>
+              <a:rPr sz="1800" b="1">
+                <a:solidFill>
+                  <a:srgbClr val="FFFFFF"/>
+                </a:solidFill>
+                <a:latin typeface="Noto Sans KR"/>
+                <a:ea typeface="Noto Sans KR"/>
+                <a:cs typeface="Noto Sans KR"/>
+              </a:rPr>
+              <a:t>리플레이 분석 확장</a:t>
             </a:r>
           </a:p>
         </p:txBody>
@@ -6296,22 +6359,25 @@
           <a:p xmlns:a="http://schemas.openxmlformats.org/drawingml/2006/main">
             <a:pPr marL="0" indent="0">
               <a:buNone/>
-              <a:defRPr>
-                <a:latin typeface="Noto Sans KR"/>
-                <a:ea typeface="Noto Sans KR"/>
-                <a:cs typeface="Noto Sans KR"/>
-              </a:defRPr>
-            </a:pPr>
-            <a:r>
-              <a:rPr sz="1250">
-                <a:solidFill>
-                  <a:srgbClr val="AEBDD0"/>
-                </a:solidFill>
-                <a:latin typeface="Malgun Gothic"/>
-                <a:ea typeface="Malgun Gothic"/>
-                <a:cs typeface="Malgun Gothic"/>
-              </a:rPr>
-              <a:t>대표 장면 자동 후보 → 본인이 선택해 공개, 끝난 경기를 중계처럼 재생</a:t>
+              <a:defRPr sz="1350">
+                <a:solidFill>
+                  <a:srgbClr val="B8C4D1"/>
+                </a:solidFill>
+                <a:latin typeface="Noto Sans KR"/>
+                <a:ea typeface="Noto Sans KR"/>
+                <a:cs typeface="Noto Sans KR"/>
+              </a:defRPr>
+            </a:pPr>
+            <a:r>
+              <a:rPr sz="1350">
+                <a:solidFill>
+                  <a:srgbClr val="B8C4D1"/>
+                </a:solidFill>
+                <a:latin typeface="Noto Sans KR"/>
+                <a:ea typeface="Noto Sans KR"/>
+                <a:cs typeface="Noto Sans KR"/>
+              </a:rPr>
+              <a:t>미니맵에서 10인 위치와 시야를 추출해 주요 장면의 판단 근거를 보강</a:t>
             </a:r>
           </a:p>
         </p:txBody>
@@ -10428,7 +10494,7 @@
           <p:nvPr/>
         </p:nvPicPr>
         <p:blipFill>
-          <a:blip xmlns:r="http://schemas.openxmlformats.org/officeDocument/2006/relationships" xmlns:a="http://schemas.openxmlformats.org/drawingml/2006/main" r:embed="R71b70a0cc3e64191"/>
+          <a:blip xmlns:r="http://schemas.openxmlformats.org/officeDocument/2006/relationships" xmlns:a="http://schemas.openxmlformats.org/drawingml/2006/main" r:embed="R0e516496b923403d"/>
           <a:srcRect xmlns:a="http://schemas.openxmlformats.org/drawingml/2006/main" l="-25498" t="0" r="-25498" b="0"/>
           <a:stretch xmlns:a="http://schemas.openxmlformats.org/drawingml/2006/main"/>
         </p:blipFill>
@@ -10541,7 +10607,7 @@
           <p:nvPr/>
         </p:nvPicPr>
         <p:blipFill>
-          <a:blip xmlns:r="http://schemas.openxmlformats.org/officeDocument/2006/relationships" xmlns:a="http://schemas.openxmlformats.org/drawingml/2006/main" r:embed="R7142ed8bd0a14628"/>
+          <a:blip xmlns:r="http://schemas.openxmlformats.org/officeDocument/2006/relationships" xmlns:a="http://schemas.openxmlformats.org/drawingml/2006/main" r:embed="Rd427c47e26ea4b5b"/>
           <a:srcRect xmlns:a="http://schemas.openxmlformats.org/drawingml/2006/main" l="-25815" t="0" r="-25815" b="0"/>
           <a:stretch xmlns:a="http://schemas.openxmlformats.org/drawingml/2006/main"/>
         </p:blipFill>
@@ -12996,7 +13062,7 @@
           <p:nvPr/>
         </p:nvPicPr>
         <p:blipFill>
-          <a:blip xmlns:r="http://schemas.openxmlformats.org/officeDocument/2006/relationships" xmlns:a="http://schemas.openxmlformats.org/drawingml/2006/main" r:embed="R56a89b6799e940f7"/>
+          <a:blip xmlns:r="http://schemas.openxmlformats.org/officeDocument/2006/relationships" xmlns:a="http://schemas.openxmlformats.org/drawingml/2006/main" r:embed="R11a13ba68268458f"/>
           <a:srcRect xmlns:a="http://schemas.openxmlformats.org/drawingml/2006/main" l="0" t="0" r="0" b="0"/>
           <a:stretch xmlns:a="http://schemas.openxmlformats.org/drawingml/2006/main"/>
         </p:blipFill>
@@ -13109,7 +13175,7 @@
           <p:nvPr/>
         </p:nvPicPr>
         <p:blipFill>
-          <a:blip xmlns:r="http://schemas.openxmlformats.org/officeDocument/2006/relationships" xmlns:a="http://schemas.openxmlformats.org/drawingml/2006/main" r:embed="Raa6c91abe0074f24"/>
+          <a:blip xmlns:r="http://schemas.openxmlformats.org/officeDocument/2006/relationships" xmlns:a="http://schemas.openxmlformats.org/drawingml/2006/main" r:embed="R1c93c447a2e44dbd"/>
           <a:srcRect xmlns:a="http://schemas.openxmlformats.org/drawingml/2006/main" l="-25815" t="0" r="-25815" b="0"/>
           <a:stretch xmlns:a="http://schemas.openxmlformats.org/drawingml/2006/main"/>
         </p:blipFill>

</xml_diff>